<commit_message>
Dar kapsamlı tam metni yaz ve tezdeki iki hatayı düzelt
Tam metin 3114 kelime gövde ve 23 kaynakla yazıldı. Kabul edilen özette
söz verilen her sonuç karşılandı; özgün analitik katkılar (katı derişimi
regresyonu, dirençlilik modülü türetmesi, iki karşılaştırma bloğu,
Materiom çerçevesi, tasarım önerisi) bilerek dışarıda bırakıldı ve dergi
makalesine saklandı. Formülasyon tablosu ham kütlelerle verildi,
türetilmiş oran sütunları çıkarıldı.

Tezde iki hata tespit edildi ve düzeltildi. Gövde metni ISO 11925-1
diyor ancak kaynakça doğru olanı veriyor: ISO 11925-2, tek kaynaklı alev
testi. Part 1 kılavuz, Part 2 test yöntemidir; sunum ve tüm notlar
düzeltildi. Ayrıca tezin gövdesinde atıf verilen sekiz kaynağın
kaynakçada yer almadığı ve üç yıl tutarsızlığı bulunduğu saptandı;
tam metinde yalnızca doğrulanmış künyeler kullanıldı.

Co-Authored-By: Claude Opus 5 <noreply@anthropic.com>
Claude-Session: https://claude.ai/code/session_01N92FbpMhSF7GJYZXiJxxP2
</commit_message>
<xml_diff>
--- a/konferans-bildirisi/06-sunum/ICSMMEP26_Presentation_Unal.pptx
+++ b/konferans-bildirisi/06-sunum/ICSMMEP26_Presentation_Unal.pptx
@@ -129,7 +129,7 @@
   <p:extLst>
     <p:ext uri="{521415D9-36F7-43E2-AB2F-B90AF26B5E84}">
       <p14:sectionLst xmlns:p14="http://schemas.microsoft.com/office/powerpoint/2010/main">
-        <p14:section name="Introduction" id="{8c258224-402f-9135-5125-10cf2eeb607e}">
+        <p14:section name="Introduction" id="{28797173-b0c8-3356-6b60-5decabd07242}">
           <p14:sldIdLst>
             <p14:sldId id="256"/>
             <p14:sldId id="257"/>
@@ -138,7 +138,7 @@
             <p14:sldId id="260"/>
           </p14:sldIdLst>
         </p14:section>
-        <p14:section name="Production" id="{3dc5fff5-cd0d-1755-9d01-528a076685da}">
+        <p14:section name="Production" id="{0ae8fcf8-2b67-da35-a503-05a60d987fd4}">
           <p14:sldIdLst>
             <p14:sldId id="261"/>
             <p14:sldId id="262"/>
@@ -146,7 +146,7 @@
             <p14:sldId id="264"/>
           </p14:sldIdLst>
         </p14:section>
-        <p14:section name="Characterisation" id="{a591debf-cce5-a24e-c409-1cfb89f768fd}">
+        <p14:section name="Characterisation" id="{376a87e2-f52b-1f01-91d8-f03b37a52d32}">
           <p14:sldIdLst>
             <p14:sldId id="265"/>
             <p14:sldId id="266"/>
@@ -156,20 +156,20 @@
             <p14:sldId id="270"/>
           </p14:sldIdLst>
         </p14:section>
-        <p14:section name="Benchmarking" id="{30f53cfb-3948-35df-661b-57aa9e1a416c}">
+        <p14:section name="Benchmarking" id="{1383be96-b2eb-5695-4add-8722f42ac09b}">
           <p14:sldIdLst>
             <p14:sldId id="271"/>
             <p14:sldId id="272"/>
             <p14:sldId id="273"/>
           </p14:sldIdLst>
         </p14:section>
-        <p14:section name="Application" id="{70f348c0-ce2d-9a4d-d318-9d76b5ccdef0}">
+        <p14:section name="Application" id="{b5957017-fef1-0b99-9f72-c90151351b58}">
           <p14:sldIdLst>
             <p14:sldId id="274"/>
             <p14:sldId id="275"/>
           </p14:sldIdLst>
         </p14:section>
-        <p14:section name="Closing" id="{83228d9b-eb96-86ff-4bf0-14b34f475186}">
+        <p14:section name="Closing" id="{b5d71cec-079f-ee11-83f8-50aae2c7bb8c}">
           <p14:sldIdLst>
             <p14:sldId id="276"/>
             <p14:sldId id="277"/>
@@ -1807,7 +1807,7 @@
           <a:p>
             <a:r>
               <a:rPr lang="en-US" dirty="0"/>
-              <a:t>Three environmental properties together. On fire: ignition at around ten seconds under direct flame, self-extinguishing four seconds after removal, charring local, no lateral spread, and no melting or dripping. The probable mechanism is endothermic carbonate decomposition releasing carbon dioxide, which dilutes the flame front - not verified calorimetrically. And to be explicit: 11925-1 is an ignitability test. No Euroclass, no cone calorimetry, no smoke or toxicity data. On water: 0.7 percent mass gain over twenty-four hours with three shellac coats, with local dissolution where the coating was thin - so coating integrity is the limiting factor, not the composite. On density: 1.38, between the fungal and cellulosic materials below and fired clay above, and quoted on a mould-volume basis so it is a lower bound.</a:t>
+              <a:t>Three environmental properties together. On fire: ignition at around ten seconds under direct flame, self-extinguishing four seconds after removal, charring local, no lateral spread, and no melting or dripping. The probable mechanism is endothermic carbonate decomposition releasing carbon dioxide, which dilutes the flame front - not verified calorimetrically. And to be explicit: 11925-2 is an ignitability test. No Euroclass, no cone calorimetry, no smoke or toxicity data. On water: 0.7 percent mass gain over twenty-four hours with three shellac coats, with local dissolution where the coating was thin - so coating integrity is the limiting factor, not the composite. On density: 1.38, between the fungal and cellulosic materials below and fired clay above, and quoted on a mould-volume basis so it is a lower bound.</a:t>
             </a:r>
             <a:endParaRPr lang="en-US" dirty="0"/>
           </a:p>
@@ -9917,7 +9917,7 @@
                           <a:ea typeface="Calibri" pitchFamily="34" charset="-122"/>
                           <a:cs typeface="Calibri" pitchFamily="34" charset="-120"/>
                         </a:rPr>
-                        <a:t>ISO 11925-1</a:t>
+                        <a:t>ISO 11925-2</a:t>
                       </a:r>
                       <a:endParaRPr lang="en-US" sz="1200" dirty="0">
                         <a:latin typeface="Calibri" charset="0"/>
@@ -14887,7 +14887,7 @@
                   <a:schemeClr val="accent1"/>
                 </a:solidFill>
               </a:rPr>
-              <a:t>IGNITABILITY — ISO 11925-1</a:t>
+              <a:t>IGNITABILITY — ISO 11925-2</a:t>
             </a:r>
             <a:endParaRPr lang="en-US" sz="1200" dirty="0"/>
           </a:p>
@@ -15206,7 +15206,7 @@
                   <a:schemeClr val="accent1"/>
                 </a:solidFill>
               </a:rPr>
-              <a:t>Probable mechanism: endothermic carbonate decomposition releasing CO₂, diluting the flame front locally. Not verified calorimetrically. ISO 11925-1 is an ignitability test — no Euroclass classification, cone calorimetry, smoke or toxicity data were obtained.</a:t>
+              <a:t>Probable mechanism: endothermic carbonate decomposition releasing CO₂, diluting the flame front locally. Not verified calorimetrically. ISO 11925-2 is an ignitability test — no Euroclass classification, cone calorimetry, smoke or toxicity data were obtained.</a:t>
             </a:r>
             <a:endParaRPr lang="en-US" sz="1050" dirty="0"/>
           </a:p>
@@ -26598,7 +26598,7 @@
                   <a:schemeClr val="accent6"/>
                 </a:solidFill>
               </a:rPr>
-              <a:t>Standards: ASTM D790-17 · ISO 11925-1:2020 · ASTM D570-98(2018).   Full reference list available on request.</a:t>
+              <a:t>Standards: ASTM D790-17 · ISO 11925-2:2020 · ASTM D570-98(2018).   Full reference list available on request.</a:t>
             </a:r>
             <a:endParaRPr lang="en-US" sz="1050" dirty="0"/>
           </a:p>
@@ -29360,7 +29360,7 @@
                   <a:schemeClr val="accent6"/>
                 </a:solidFill>
               </a:rPr>
-              <a:t>Standardised tests: ASTM D790, ISO 11925-1, ASTM D570</a:t>
+              <a:t>Standardised tests: ASTM D790, ISO 11925-2, ASTM D570</a:t>
             </a:r>
             <a:endParaRPr lang="en-US" sz="1250" dirty="0"/>
           </a:p>

</xml_diff>

<commit_message>
Her slayta konuşma metninden birebir bir cümle koy
Slaytlar tamamen boşaltıldıktan sonra denge kuruldu: her slaytta artık konuşma
metninden birebir alınmış en az bir cümle duruyor. Paragraf geri gelmedi, yalnız
tek cümle; geri kalan hâlâ veri ve diyagram.

Önceki turda slayttaki satırlar ile metindeki cümleler yakın ama aynı değildi.
Yirmi dört slaytta ikisi birbirine eşitlendi, böylece konuşmacı ekrandan
okuduğunda metinden sapmıyor. İki cümle de metne geri eklendi: basma kırılma
biçimi ve eğilmede geçişin keskinliği.

Konuşma metninde slaytta duran cümleler kalın yazıldı. Kalın olan ekrandan
okunabilir, düz olan ekrana bakmadan söylenir; basılı metinde bu ayrım bir
bakışta görünüyor.

Metin bin beş yüz seksen kelime, on bir dakika; sahnede on iki buçuk dakika
civarı.

Co-Authored-By: Claude Opus 5 <noreply@anthropic.com>
Claude-Session: https://claude.ai/code/session_01N92FbpMhSF7GJYZXiJxxP2
</commit_message>
<xml_diff>
--- a/konferans-bildirisi/06-sunum/ICSMMEP26_Presentation_Unal.pptx
+++ b/konferans-bildirisi/06-sunum/ICSMMEP26_Presentation_Unal.pptx
@@ -133,12 +133,12 @@
   <p:extLst>
     <p:ext uri="{521415D9-36F7-43E2-AB2F-B90AF26B5E84}">
       <p14:sectionLst xmlns:p14="http://schemas.microsoft.com/office/powerpoint/2010/main">
-        <p14:section name="Opening" id="{83522892-8058-46af-2bcf-f89f6d23ec92}">
+        <p14:section name="Opening" id="{2b42375b-a05a-1109-3d16-f97a92c1bed3}">
           <p14:sldIdLst>
             <p14:sldId id="256"/>
           </p14:sldIdLst>
         </p14:section>
-        <p14:section name="Introduction" id="{d3e3db9d-8905-1cbf-93e0-ba55bc9d1eed}">
+        <p14:section name="Introduction" id="{9377a455-dcce-9151-95e9-1c541672c8e3}">
           <p14:sldIdLst>
             <p14:sldId id="257"/>
             <p14:sldId id="258"/>
@@ -146,7 +146,7 @@
             <p14:sldId id="260"/>
           </p14:sldIdLst>
         </p14:section>
-        <p14:section name="Framework" id="{12e672a2-25d8-d0a6-031d-30d5e1669357}">
+        <p14:section name="Framework" id="{0457e436-839e-4e23-42df-7c70342edf4d}">
           <p14:sldIdLst>
             <p14:sldId id="261"/>
             <p14:sldId id="262"/>
@@ -155,7 +155,7 @@
             <p14:sldId id="265"/>
           </p14:sldIdLst>
         </p14:section>
-        <p14:section name="Protocol" id="{96cbed27-9dbe-0e12-9755-6b3882323c94}">
+        <p14:section name="Protocol" id="{31bcd4c8-9ec2-a33d-f084-a220ad5ccab7}">
           <p14:sldIdLst>
             <p14:sldId id="266"/>
             <p14:sldId id="267"/>
@@ -163,7 +163,7 @@
             <p14:sldId id="269"/>
           </p14:sldIdLst>
         </p14:section>
-        <p14:section name="Results" id="{7df4e7b1-21b8-5754-6a23-805a975f3468}">
+        <p14:section name="Results" id="{8b2f5c2e-a813-c02d-20d3-e87570d3e9d1}">
           <p14:sldIdLst>
             <p14:sldId id="270"/>
             <p14:sldId id="271"/>
@@ -173,19 +173,19 @@
             <p14:sldId id="275"/>
           </p14:sldIdLst>
         </p14:section>
-        <p14:section name="Benchmark" id="{ad674ddf-a3f6-e94c-7d02-89a4c44ed805}">
+        <p14:section name="Benchmark" id="{6a9909b2-fc2a-502e-e024-371c5b1bba83}">
           <p14:sldIdLst>
             <p14:sldId id="276"/>
             <p14:sldId id="277"/>
             <p14:sldId id="278"/>
           </p14:sldIdLst>
         </p14:section>
-        <p14:section name="Application" id="{fb6a8011-9648-d6f5-c1bd-fef49a4d7078}">
+        <p14:section name="Application" id="{aa91c2ba-4a00-9eb0-4b84-9a2d62d8ace3}">
           <p14:sldIdLst>
             <p14:sldId id="279"/>
           </p14:sldIdLst>
         </p14:section>
-        <p14:section name="Closing" id="{5bd55812-bfad-f204-0c4d-a23fa6b69c6d}">
+        <p14:section name="Closing" id="{b0f40cd2-36d8-e657-1ad3-3e5f34ccc477}">
           <p14:sldIdLst>
             <p14:sldId id="280"/>
             <p14:sldId id="281"/>
@@ -4953,7 +4953,7 @@
         <p:spPr>
           <a:xfrm>
             <a:off x="731520" y="5806440"/>
-            <a:ext cx="10698480" cy="457200"/>
+            <a:ext cx="10241280" cy="457200"/>
           </a:xfrm>
           <a:prstGeom prst="rect">
             <a:avLst/>
@@ -4980,7 +4980,7 @@
                 <a:ea typeface="Calibri" pitchFamily="34" charset="-122"/>
                 <a:cs typeface="Calibri" pitchFamily="34" charset="-120"/>
               </a:rPr>
-              <a:t>Provenance. The dissertation from which this work derives states a broader hypothesis framed on spatial resilience in interior design. The formulation above is the materials-engineering component of it, restated within the scope of the tests reported here.</a:t>
+              <a:t>On provenance: the dissertation states a broader hypothesis framed on spatial resilience. This is its materials-engineering component, restated within the scope of these tests.</a:t>
             </a:r>
             <a:endParaRPr lang="en-US" sz="900" dirty="0"/>
           </a:p>
@@ -5987,7 +5987,49 @@
         </p:nvSpPr>
         <p:spPr>
           <a:xfrm>
-            <a:off x="731520" y="4572000"/>
+            <a:off x="731520" y="4526280"/>
+            <a:ext cx="10241280" cy="548640"/>
+          </a:xfrm>
+          <a:prstGeom prst="rect">
+            <a:avLst/>
+          </a:prstGeom>
+          <a:noFill/>
+          <a:ln/>
+        </p:spPr>
+        <p:txBody>
+          <a:bodyPr wrap="square" lIns="0" tIns="0" rIns="0" bIns="0" rtlCol="0" anchor="t"/>
+          <a:lstStyle/>
+          <a:p>
+            <a:pPr indent="0" marL="0">
+              <a:lnSpc>
+                <a:spcPts val="1800"/>
+              </a:lnSpc>
+              <a:buNone/>
+            </a:pPr>
+            <a:r>
+              <a:rPr lang="en-US" sz="1200" dirty="0">
+                <a:solidFill>
+                  <a:srgbClr val="3C3C3C"/>
+                </a:solidFill>
+                <a:latin typeface="Calibri" pitchFamily="34" charset="0"/>
+                <a:ea typeface="Calibri" pitchFamily="34" charset="-122"/>
+                <a:cs typeface="Calibri" pitchFamily="34" charset="-120"/>
+              </a:rPr>
+              <a:t>That particle size was chosen to match the eggshell polymer-composite literature, so the mineral phase here is comparable with that work.</a:t>
+            </a:r>
+            <a:endParaRPr lang="en-US" sz="1200" dirty="0"/>
+          </a:p>
+        </p:txBody>
+      </p:sp>
+      <p:sp>
+        <p:nvSpPr>
+          <p:cNvPr id="30" name="Text 28"/>
+          <p:cNvSpPr txBox="1"/>
+          <p:nvPr/>
+        </p:nvSpPr>
+        <p:spPr>
+          <a:xfrm>
+            <a:off x="731520" y="5303520"/>
             <a:ext cx="10241280" cy="457200"/>
           </a:xfrm>
           <a:prstGeom prst="rect">
@@ -6015,7 +6057,7 @@
                 <a:ea typeface="Calibri" pitchFamily="34" charset="-122"/>
                 <a:cs typeface="Calibri" pitchFamily="34" charset="-120"/>
               </a:rPr>
-              <a:t>150 µm chosen to match the particle size used in the eggshell polymer-composite literature.  ·  The 120 °C step is decontamination and drying, not sterilisation: sterility was not verified.</a:t>
+              <a:t>The 120 °C step is decontamination and drying, not sterilisation: sterility was not verified.</a:t>
             </a:r>
             <a:endParaRPr lang="en-US" sz="900" dirty="0"/>
           </a:p>
@@ -6023,7 +6065,7 @@
       </p:sp>
       <p:sp>
         <p:nvSpPr>
-          <p:cNvPr id="31" name="Text 0"/>
+          <p:cNvPr id="32" name="Text 0"/>
           <p:cNvSpPr/>
           <p:nvPr>
             <p:ph idx="100" hasCustomPrompt="1"/>
@@ -7015,7 +7057,49 @@
         </p:nvSpPr>
         <p:spPr>
           <a:xfrm>
-            <a:off x="731520" y="5715000"/>
+            <a:off x="731520" y="5532120"/>
+            <a:ext cx="10241280" cy="548640"/>
+          </a:xfrm>
+          <a:prstGeom prst="rect">
+            <a:avLst/>
+          </a:prstGeom>
+          <a:noFill/>
+          <a:ln/>
+        </p:spPr>
+        <p:txBody>
+          <a:bodyPr wrap="square" lIns="0" tIns="0" rIns="0" bIns="0" rtlCol="0" anchor="t"/>
+          <a:lstStyle/>
+          <a:p>
+            <a:pPr indent="0" marL="0">
+              <a:lnSpc>
+                <a:spcPts val="1800"/>
+              </a:lnSpc>
+              <a:buNone/>
+            </a:pPr>
+            <a:r>
+              <a:rPr lang="en-US" sz="1200" dirty="0">
+                <a:solidFill>
+                  <a:srgbClr val="3C3C3C"/>
+                </a:solidFill>
+                <a:latin typeface="Calibri" pitchFamily="34" charset="0"/>
+                <a:ea typeface="Calibri" pitchFamily="34" charset="-122"/>
+                <a:cs typeface="Calibri" pitchFamily="34" charset="-120"/>
+              </a:rPr>
+              <a:t>Agar is added incrementally under continuous stirring; bulk addition forms agglomerates that do not redisperse.</a:t>
+            </a:r>
+            <a:endParaRPr lang="en-US" sz="1200" dirty="0"/>
+          </a:p>
+        </p:txBody>
+      </p:sp>
+      <p:sp>
+        <p:nvSpPr>
+          <p:cNvPr id="31" name="Text 29"/>
+          <p:cNvSpPr txBox="1"/>
+          <p:nvPr/>
+        </p:nvSpPr>
+        <p:spPr>
+          <a:xfrm>
+            <a:off x="731520" y="6172200"/>
             <a:ext cx="10241280" cy="457200"/>
           </a:xfrm>
           <a:prstGeom prst="rect">
@@ -7043,7 +7127,7 @@
                 <a:ea typeface="Calibri" pitchFamily="34" charset="-122"/>
                 <a:cs typeface="Calibri" pitchFamily="34" charset="-120"/>
               </a:rPr>
-              <a:t>Schematic. The two set points and the total heating time are recorded; intermediate ramp rates are not. Stirring was manual, so shear rate is not a controlled quantity.</a:t>
+              <a:t>Schematic. The two set points and the total heating time are recorded; intermediate ramp rates are not. Stirring was manual.</a:t>
             </a:r>
             <a:endParaRPr lang="en-US" sz="900" dirty="0"/>
           </a:p>
@@ -7051,7 +7135,7 @@
       </p:sp>
       <p:sp>
         <p:nvSpPr>
-          <p:cNvPr id="32" name="Text 0"/>
+          <p:cNvPr id="33" name="Text 0"/>
           <p:cNvSpPr/>
           <p:nvPr>
             <p:ph idx="100" hasCustomPrompt="1"/>
@@ -7711,13 +7795,13 @@
       </p:sp>
       <p:sp>
         <p:nvSpPr>
-          <p:cNvPr id="19" name="ru0.84.5"/>
+          <p:cNvPr id="19" name="ru0.84.45"/>
           <p:cNvSpPr/>
           <p:nvPr/>
         </p:nvSpPr>
         <p:spPr>
           <a:xfrm>
-            <a:off x="731520" y="4114800"/>
+            <a:off x="731520" y="4069080"/>
             <a:ext cx="10698480" cy="9144"/>
           </a:xfrm>
           <a:prstGeom prst="rect">
@@ -7744,7 +7828,49 @@
         </p:nvSpPr>
         <p:spPr>
           <a:xfrm>
-            <a:off x="731520" y="4297680"/>
+            <a:off x="731520" y="4251960"/>
+            <a:ext cx="10241280" cy="457200"/>
+          </a:xfrm>
+          <a:prstGeom prst="rect">
+            <a:avLst/>
+          </a:prstGeom>
+          <a:noFill/>
+          <a:ln/>
+        </p:spPr>
+        <p:txBody>
+          <a:bodyPr wrap="square" lIns="0" tIns="0" rIns="0" bIns="0" rtlCol="0" anchor="t"/>
+          <a:lstStyle/>
+          <a:p>
+            <a:pPr indent="0" marL="0">
+              <a:lnSpc>
+                <a:spcPts val="1800"/>
+              </a:lnSpc>
+              <a:buNone/>
+            </a:pPr>
+            <a:r>
+              <a:rPr lang="en-US" sz="1200" dirty="0">
+                <a:solidFill>
+                  <a:srgbClr val="3C3C3C"/>
+                </a:solidFill>
+                <a:latin typeface="Calibri" pitchFamily="34" charset="0"/>
+                <a:ea typeface="Calibri" pitchFamily="34" charset="-122"/>
+                <a:cs typeface="Calibri" pitchFamily="34" charset="-120"/>
+              </a:rPr>
+              <a:t>No thermal input after the 55-minute preparation: the entire cure is at room temperature.</a:t>
+            </a:r>
+            <a:endParaRPr lang="en-US" sz="1200" dirty="0"/>
+          </a:p>
+        </p:txBody>
+      </p:sp>
+      <p:sp>
+        <p:nvSpPr>
+          <p:cNvPr id="21" name="Text 19"/>
+          <p:cNvSpPr txBox="1"/>
+          <p:nvPr/>
+        </p:nvSpPr>
+        <p:spPr>
+          <a:xfrm>
+            <a:off x="731520" y="4800600"/>
             <a:ext cx="10241280" cy="457200"/>
           </a:xfrm>
           <a:prstGeom prst="rect">
@@ -7780,14 +7906,14 @@
       </p:sp>
       <p:sp>
         <p:nvSpPr>
-          <p:cNvPr id="21" name="disc"/>
+          <p:cNvPr id="22" name="disc"/>
           <p:cNvSpPr/>
           <p:nvPr/>
         </p:nvSpPr>
         <p:spPr>
           <a:xfrm>
-            <a:off x="731520" y="5029200"/>
-            <a:ext cx="10698480" cy="731520"/>
+            <a:off x="731520" y="5349240"/>
+            <a:ext cx="10698480" cy="777240"/>
           </a:xfrm>
           <a:prstGeom prst="rect">
             <a:avLst/>
@@ -7807,14 +7933,14 @@
       </p:sp>
       <p:sp>
         <p:nvSpPr>
-          <p:cNvPr id="22" name="Text 20"/>
+          <p:cNvPr id="23" name="Text 21"/>
           <p:cNvSpPr txBox="1"/>
           <p:nvPr/>
         </p:nvSpPr>
         <p:spPr>
           <a:xfrm>
-            <a:off x="1051560" y="5166360"/>
-            <a:ext cx="10058400" cy="457200"/>
+            <a:off x="1051560" y="5486400"/>
+            <a:ext cx="10058400" cy="502920"/>
           </a:xfrm>
           <a:prstGeom prst="rect">
             <a:avLst/>
@@ -7858,7 +7984,7 @@
                 <a:ea typeface="Calibri" pitchFamily="34" charset="-122"/>
                 <a:cs typeface="Calibri" pitchFamily="34" charset="-120"/>
               </a:rPr>
-              <a:t>the composite shrinks as water evaporates, and post-drying dimensions were not logged. Every dimension quoted is a mould dimension.</a:t>
+              <a:t>the composite shrinks as water evaporates, and post-drying dimensions were not logged, so every dimension I quote is a mould dimension.</a:t>
             </a:r>
             <a:endParaRPr lang="en-US" sz="1200" dirty="0"/>
           </a:p>
@@ -7866,7 +7992,7 @@
       </p:sp>
       <p:sp>
         <p:nvSpPr>
-          <p:cNvPr id="24" name="Text 0"/>
+          <p:cNvPr id="25" name="Text 0"/>
           <p:cNvSpPr/>
           <p:nvPr>
             <p:ph idx="100" hasCustomPrompt="1"/>
@@ -12592,7 +12718,7 @@
                 <a:ea typeface="Calibri" pitchFamily="34" charset="-122"/>
                 <a:cs typeface="Calibri" pitchFamily="34" charset="-120"/>
               </a:rPr>
-              <a:t>Shell : binder fixed at 2.00. Solids concentration is the only variable in the C series.</a:t>
+              <a:t>Solids concentration is the only variable — the water band shortens from C1 to C3.</a:t>
             </a:r>
             <a:endParaRPr lang="en-US" sz="1200" dirty="0"/>
           </a:p>
@@ -13424,7 +13550,7 @@
                 <a:ea typeface="Calibri" pitchFamily="34" charset="-122"/>
                 <a:cs typeface="Calibri" pitchFamily="34" charset="-120"/>
               </a:rPr>
-              <a:t>Mechanical values are means of three specimens. No standard deviations: individual values were not retained.</a:t>
+              <a:t>Mechanical values are means of three specimens; individual values were not retained, so I cannot give standard deviations.</a:t>
             </a:r>
             <a:endParaRPr lang="en-US" sz="1200" dirty="0"/>
           </a:p>
@@ -15216,8 +15342,8 @@
         </p:nvSpPr>
         <p:spPr>
           <a:xfrm>
-            <a:off x="731520" y="3566160"/>
-            <a:ext cx="4206240" cy="1097280"/>
+            <a:off x="731520" y="3520440"/>
+            <a:ext cx="4206240" cy="731520"/>
           </a:xfrm>
           <a:prstGeom prst="rect">
             <a:avLst/>
@@ -15244,7 +15370,7 @@
                 <a:ea typeface="Calibri" pitchFamily="34" charset="-122"/>
                 <a:cs typeface="Calibri" pitchFamily="34" charset="-120"/>
               </a:rPr>
-              <a:t>Strength rises with solids concentration, not with mineral content.</a:t>
+              <a:t>Strength is governed by packing density, not by mineral content.</a:t>
             </a:r>
             <a:endParaRPr lang="en-US" sz="1200" dirty="0"/>
           </a:p>
@@ -15258,7 +15384,49 @@
         </p:nvSpPr>
         <p:spPr>
           <a:xfrm>
-            <a:off x="731520" y="4297680"/>
+            <a:off x="731520" y="4160520"/>
+            <a:ext cx="4206240" cy="822960"/>
+          </a:xfrm>
+          <a:prstGeom prst="rect">
+            <a:avLst/>
+          </a:prstGeom>
+          <a:noFill/>
+          <a:ln/>
+        </p:spPr>
+        <p:txBody>
+          <a:bodyPr wrap="square" lIns="0" tIns="0" rIns="0" bIns="0" rtlCol="0" anchor="t"/>
+          <a:lstStyle/>
+          <a:p>
+            <a:pPr indent="0" marL="0">
+              <a:lnSpc>
+                <a:spcPts val="1800"/>
+              </a:lnSpc>
+              <a:buNone/>
+            </a:pPr>
+            <a:r>
+              <a:rPr lang="en-US" sz="1200" dirty="0">
+                <a:solidFill>
+                  <a:srgbClr val="3C3C3C"/>
+                </a:solidFill>
+                <a:latin typeface="Calibri" pitchFamily="34" charset="0"/>
+                <a:ea typeface="Calibri" pitchFamily="34" charset="-122"/>
+                <a:cs typeface="Calibri" pitchFamily="34" charset="-120"/>
+              </a:rPr>
+              <a:t>The route to a stronger composite is to remove water, not to add shell.</a:t>
+            </a:r>
+            <a:endParaRPr lang="en-US" sz="1200" dirty="0"/>
+          </a:p>
+        </p:txBody>
+      </p:sp>
+      <p:sp>
+        <p:nvSpPr>
+          <p:cNvPr id="8" name="Text 5"/>
+          <p:cNvSpPr txBox="1"/>
+          <p:nvPr/>
+        </p:nvSpPr>
+        <p:spPr>
+          <a:xfrm>
+            <a:off x="731520" y="5257800"/>
             <a:ext cx="4206240" cy="457200"/>
           </a:xfrm>
           <a:prstGeom prst="rect">
@@ -15294,7 +15462,7 @@
       </p:sp>
       <p:graphicFrame>
         <p:nvGraphicFramePr>
-          <p:cNvPr id="8" name="cc" descr=""/>
+          <p:cNvPr id="9" name="cc" descr=""/>
           <p:cNvGraphicFramePr/>
           <p:nvPr/>
         </p:nvGraphicFramePr>
@@ -15310,7 +15478,7 @@
       </p:graphicFrame>
       <p:sp>
         <p:nvSpPr>
-          <p:cNvPr id="9" name="Text 5"/>
+          <p:cNvPr id="10" name="Text 6"/>
           <p:cNvSpPr txBox="1"/>
           <p:nvPr/>
         </p:nvSpPr>
@@ -15352,7 +15520,7 @@
       </p:sp>
       <p:sp>
         <p:nvSpPr>
-          <p:cNvPr id="11" name="Text 0"/>
+          <p:cNvPr id="12" name="Text 0"/>
           <p:cNvSpPr/>
           <p:nvPr>
             <p:ph idx="100" hasCustomPrompt="1"/>
@@ -15769,7 +15937,7 @@
         <p:spPr>
           <a:xfrm>
             <a:off x="9144000" y="3200400"/>
-            <a:ext cx="2286000" cy="1097280"/>
+            <a:ext cx="2286000" cy="1463040"/>
           </a:xfrm>
           <a:prstGeom prst="rect">
             <a:avLst/>
@@ -15796,7 +15964,7 @@
                 <a:ea typeface="Calibri" pitchFamily="34" charset="-122"/>
                 <a:cs typeface="Calibri" pitchFamily="34" charset="-120"/>
               </a:rPr>
-              <a:t>Energy absorbed, not released. Still a single body after test.</a:t>
+              <a:t>The cube has barrelled. It is shorter and wider, and still a single body.</a:t>
             </a:r>
             <a:endParaRPr lang="en-US" sz="1200" dirty="0"/>
           </a:p>
@@ -17340,7 +17508,7 @@
         <p:spPr>
           <a:xfrm>
             <a:off x="5303520" y="3611880"/>
-            <a:ext cx="2286000" cy="1097280"/>
+            <a:ext cx="2286000" cy="1280160"/>
           </a:xfrm>
           <a:prstGeom prst="rect">
             <a:avLst/>
@@ -17367,7 +17535,7 @@
                 <a:ea typeface="Calibri" pitchFamily="34" charset="-122"/>
                 <a:cs typeface="Calibri" pitchFamily="34" charset="-120"/>
               </a:rPr>
-              <a:t>The transition lies between these two values.</a:t>
+              <a:t>The transition is sharp, and it lies between those two values.</a:t>
             </a:r>
             <a:endParaRPr lang="en-US" sz="1200" dirty="0"/>
           </a:p>
@@ -17863,7 +18031,7 @@
                 <a:ea typeface="Calibri" pitchFamily="34" charset="-122"/>
                 <a:cs typeface="Calibri" pitchFamily="34" charset="-120"/>
               </a:rPr>
-              <a:t>Substantial deformation with retained integrity, in both test programmes.</a:t>
+              <a:t>Both test programmes gave the same result: substantial deformation with retained integrity.</a:t>
             </a:r>
             <a:endParaRPr lang="en-US" sz="1200" dirty="0"/>
           </a:p>
@@ -18684,7 +18852,7 @@
         <p:spPr>
           <a:xfrm>
             <a:off x="6309360" y="4846320"/>
-            <a:ext cx="5120640" cy="914400"/>
+            <a:ext cx="5120640" cy="1097280"/>
           </a:xfrm>
           <a:prstGeom prst="rect">
             <a:avLst/>
@@ -18711,7 +18879,7 @@
                 <a:ea typeface="Calibri" pitchFamily="34" charset="-122"/>
                 <a:cs typeface="Calibri" pitchFamily="34" charset="-120"/>
               </a:rPr>
-              <a:t>The mineral phase is settled. This paper is about the binder.</a:t>
+              <a:t>The case for eggshell as a mineral phase is settled. This paper is about the binder.</a:t>
             </a:r>
             <a:endParaRPr lang="en-US" sz="1200" dirty="0"/>
           </a:p>
@@ -19138,7 +19306,49 @@
         </p:nvSpPr>
         <p:spPr>
           <a:xfrm>
-            <a:off x="3200400" y="5303520"/>
+            <a:off x="3200400" y="5257800"/>
+            <a:ext cx="3017520" cy="731520"/>
+          </a:xfrm>
+          <a:prstGeom prst="rect">
+            <a:avLst/>
+          </a:prstGeom>
+          <a:noFill/>
+          <a:ln/>
+        </p:spPr>
+        <p:txBody>
+          <a:bodyPr wrap="square" lIns="0" tIns="0" rIns="0" bIns="0" rtlCol="0" anchor="t"/>
+          <a:lstStyle/>
+          <a:p>
+            <a:pPr indent="0" marL="0">
+              <a:lnSpc>
+                <a:spcPts val="1800"/>
+              </a:lnSpc>
+              <a:buNone/>
+            </a:pPr>
+            <a:r>
+              <a:rPr lang="en-US" sz="1200" dirty="0">
+                <a:solidFill>
+                  <a:srgbClr val="3C3C3C"/>
+                </a:solidFill>
+                <a:latin typeface="Calibri" pitchFamily="34" charset="0"/>
+                <a:ea typeface="Calibri" pitchFamily="34" charset="-122"/>
+                <a:cs typeface="Calibri" pitchFamily="34" charset="-120"/>
+              </a:rPr>
+              <a:t>This is an ignitability test; there is no Euroclass classification.</a:t>
+            </a:r>
+            <a:endParaRPr lang="en-US" sz="1200" dirty="0"/>
+          </a:p>
+        </p:txBody>
+      </p:sp>
+      <p:sp>
+        <p:nvSpPr>
+          <p:cNvPr id="11" name="Text 8"/>
+          <p:cNvSpPr txBox="1"/>
+          <p:nvPr/>
+        </p:nvSpPr>
+        <p:spPr>
+          <a:xfrm>
+            <a:off x="3200400" y="6080760"/>
             <a:ext cx="3017520" cy="457200"/>
           </a:xfrm>
           <a:prstGeom prst="rect">
@@ -19166,7 +19376,7 @@
                 <a:ea typeface="Calibri" pitchFamily="34" charset="-122"/>
                 <a:cs typeface="Calibri" pitchFamily="34" charset="-120"/>
               </a:rPr>
-              <a:t>ISO 11925-2:2020. Ignitability only: no Euroclass classification, cone calorimetry, smoke or toxicity data.</a:t>
+              <a:t>ISO 11925-2:2020. No cone calorimetry, smoke or toxicity data.</a:t>
             </a:r>
             <a:endParaRPr lang="en-US" sz="900" dirty="0"/>
           </a:p>
@@ -19174,7 +19384,7 @@
       </p:sp>
       <p:sp>
         <p:nvSpPr>
-          <p:cNvPr id="11" name="vr7.31.45"/>
+          <p:cNvPr id="12" name="vr7.31.45"/>
           <p:cNvSpPr/>
           <p:nvPr/>
         </p:nvSpPr>
@@ -19201,7 +19411,7 @@
       </p:sp>
       <p:sp>
         <p:nvSpPr>
-          <p:cNvPr id="12" name="Text 9"/>
+          <p:cNvPr id="13" name="Text 10"/>
           <p:cNvSpPr txBox="1"/>
           <p:nvPr/>
         </p:nvSpPr>
@@ -19240,7 +19450,7 @@
       </p:sp>
       <p:sp>
         <p:nvSpPr>
-          <p:cNvPr id="13" name="Text 10"/>
+          <p:cNvPr id="14" name="Text 11"/>
           <p:cNvSpPr txBox="1"/>
           <p:nvPr/>
         </p:nvSpPr>
@@ -19279,7 +19489,7 @@
       </p:sp>
       <p:sp>
         <p:nvSpPr>
-          <p:cNvPr id="14" name="Text 11"/>
+          <p:cNvPr id="15" name="Text 12"/>
           <p:cNvSpPr txBox="1"/>
           <p:nvPr/>
         </p:nvSpPr>
@@ -19321,7 +19531,7 @@
       </p:sp>
       <p:sp>
         <p:nvSpPr>
-          <p:cNvPr id="15" name="ru7.83.2"/>
+          <p:cNvPr id="16" name="ru7.83.2"/>
           <p:cNvSpPr/>
           <p:nvPr/>
         </p:nvSpPr>
@@ -19348,7 +19558,7 @@
       </p:sp>
       <p:sp>
         <p:nvSpPr>
-          <p:cNvPr id="16" name="Text 13"/>
+          <p:cNvPr id="17" name="Text 14"/>
           <p:cNvSpPr txBox="1"/>
           <p:nvPr/>
         </p:nvSpPr>
@@ -20242,7 +20452,7 @@
       </p:graphicFrame>
       <p:sp>
         <p:nvSpPr>
-          <p:cNvPr id="18" name="Text 14"/>
+          <p:cNvPr id="19" name="Text 15"/>
           <p:cNvSpPr txBox="1"/>
           <p:nvPr/>
         </p:nvSpPr>
@@ -20284,7 +20494,7 @@
       </p:sp>
       <p:sp>
         <p:nvSpPr>
-          <p:cNvPr id="20" name="Text 0"/>
+          <p:cNvPr id="21" name="Text 0"/>
           <p:cNvSpPr/>
           <p:nvPr>
             <p:ph idx="100" hasCustomPrompt="1"/>
@@ -20536,7 +20746,7 @@
                 <a:ea typeface="Calibri" pitchFamily="34" charset="-122"/>
                 <a:cs typeface="Calibri" pitchFamily="34" charset="-120"/>
               </a:rPr>
-              <a:t>On strength alone the composite is not competitive with engineered wood or stone.</a:t>
+              <a:t>On strength alone this composite is not competitive with engineered wood or stone.</a:t>
             </a:r>
             <a:endParaRPr lang="en-US" sz="1200" dirty="0"/>
           </a:p>
@@ -22888,7 +23098,7 @@
                 <a:ea typeface="Calibri" pitchFamily="34" charset="-122"/>
                 <a:cs typeface="Calibri" pitchFamily="34" charset="-120"/>
               </a:rPr>
-              <a:t>Water-cast and ambient-dried, the composite attains the stiffness range of melt-processed bio-polymers.</a:t>
+              <a:t>Water-cast, dried at room temperature, no oven, no autoclave, no extruder — and it reaches the stiffness of melt-processed bio-polymers.</a:t>
             </a:r>
             <a:endParaRPr lang="en-US" sz="1200" dirty="0"/>
           </a:p>
@@ -23464,8 +23674,8 @@
         </p:nvSpPr>
         <p:spPr>
           <a:xfrm>
-            <a:off x="6217920" y="3520440"/>
-            <a:ext cx="2926080" cy="1097280"/>
+            <a:off x="6217920" y="3474720"/>
+            <a:ext cx="2926080" cy="822960"/>
           </a:xfrm>
           <a:prstGeom prst="rect">
             <a:avLst/>
@@ -23492,7 +23702,7 @@
                 <a:ea typeface="Calibri" pitchFamily="34" charset="-122"/>
                 <a:cs typeface="Calibri" pitchFamily="34" charset="-120"/>
               </a:rPr>
-              <a:t>Elastic modulus appears in the denominator.</a:t>
+              <a:t>Notice where the modulus sits: in the denominator.</a:t>
             </a:r>
             <a:endParaRPr lang="en-US" sz="1200" dirty="0"/>
           </a:p>
@@ -23506,8 +23716,8 @@
         </p:nvSpPr>
         <p:spPr>
           <a:xfrm>
-            <a:off x="6217920" y="4572000"/>
-            <a:ext cx="2926080" cy="1097280"/>
+            <a:off x="6217920" y="4389120"/>
+            <a:ext cx="2926080" cy="1737360"/>
           </a:xfrm>
           <a:prstGeom prst="rect">
             <a:avLst/>
@@ -23534,7 +23744,7 @@
                 <a:ea typeface="Calibri" pitchFamily="34" charset="-122"/>
                 <a:cs typeface="Calibri" pitchFamily="34" charset="-120"/>
               </a:rPr>
-              <a:t>The low modulus that counted against the material is what raises this quantity.</a:t>
+              <a:t>Strength records the load at which a material stops performing, not whether it then fails gracefully or catastrophically.</a:t>
             </a:r>
             <a:endParaRPr lang="en-US" sz="1200" dirty="0"/>
           </a:p>
@@ -24398,8 +24608,8 @@
         </p:nvSpPr>
         <p:spPr>
           <a:xfrm>
-            <a:off x="731520" y="5806440"/>
-            <a:ext cx="4206240" cy="457200"/>
+            <a:off x="731520" y="5760720"/>
+            <a:ext cx="4206240" cy="731520"/>
           </a:xfrm>
           <a:prstGeom prst="rect">
             <a:avLst/>
@@ -24413,22 +24623,22 @@
           <a:p>
             <a:pPr indent="0" marL="0">
               <a:lnSpc>
-                <a:spcPts val="1250"/>
+                <a:spcPts val="1750"/>
               </a:lnSpc>
               <a:buNone/>
             </a:pPr>
             <a:r>
-              <a:rPr lang="en-US" sz="900" dirty="0">
+              <a:rPr lang="en-US" sz="1150" dirty="0">
                 <a:solidFill>
-                  <a:srgbClr val="BDBDBD"/>
+                  <a:srgbClr val="3C3C3C"/>
                 </a:solidFill>
                 <a:latin typeface="Calibri" pitchFamily="34" charset="0"/>
                 <a:ea typeface="Calibri" pitchFamily="34" charset="-122"/>
                 <a:cs typeface="Calibri" pitchFamily="34" charset="-120"/>
               </a:rPr>
-              <a:t>No life-cycle assessment was carried out. These are qualitative potentials grounded in the protocol, not quantified claims.</a:t>
-            </a:r>
-            <a:endParaRPr lang="en-US" sz="900" dirty="0"/>
+              <a:t>No life-cycle assessment was carried out, so these are qualitative potentials.</a:t>
+            </a:r>
+            <a:endParaRPr lang="en-US" sz="1150" dirty="0"/>
           </a:p>
         </p:txBody>
       </p:sp>
@@ -25624,7 +25834,7 @@
                 <a:ea typeface="Calibri" pitchFamily="34" charset="-122"/>
                 <a:cs typeface="Calibri" pitchFamily="34" charset="-120"/>
               </a:rPr>
-              <a:t>Every value reported today is a lower bound. None of these limitations is unknown, and each one has a defined next experiment.</a:t>
+              <a:t>Every value I reported today is a lower bound. I would rather set these out than have them found.</a:t>
             </a:r>
             <a:endParaRPr lang="en-US" sz="1200" dirty="0"/>
           </a:p>
@@ -30026,7 +30236,7 @@
         <p:spPr>
           <a:xfrm>
             <a:off x="731520" y="5376672"/>
-            <a:ext cx="10698480" cy="274320"/>
+            <a:ext cx="10241280" cy="365760"/>
           </a:xfrm>
           <a:prstGeom prst="rect">
             <a:avLst/>
@@ -30035,14 +30245,17 @@
           <a:ln/>
         </p:spPr>
         <p:txBody>
-          <a:bodyPr wrap="square" lIns="0" tIns="0" rIns="0" bIns="0" rtlCol="0" anchor="ctr"/>
+          <a:bodyPr wrap="square" lIns="0" tIns="0" rIns="0" bIns="0" rtlCol="0" anchor="t"/>
           <a:lstStyle/>
           <a:p>
             <a:pPr indent="0" marL="0">
-              <a:buNone/>
-            </a:pPr>
-            <a:r>
-              <a:rPr lang="en-US" sz="1300" b="1" dirty="0">
+              <a:lnSpc>
+                <a:spcPts val="1800"/>
+              </a:lnSpc>
+              <a:buNone/>
+            </a:pPr>
+            <a:r>
+              <a:rPr lang="en-US" sz="1200" b="1" dirty="0">
                 <a:solidFill>
                   <a:srgbClr val="141414"/>
                 </a:solidFill>
@@ -30050,9 +30263,9 @@
                 <a:ea typeface="Calibri" pitchFamily="34" charset="-122"/>
                 <a:cs typeface="Calibri" pitchFamily="34" charset="-120"/>
               </a:rPr>
-              <a:t>What every row above has in common</a:t>
-            </a:r>
-            <a:endParaRPr lang="en-US" sz="1300" dirty="0"/>
+              <a:t>The burden is carried by the binder, and the binder is untouched.</a:t>
+            </a:r>
+            <a:endParaRPr lang="en-US" sz="1200" dirty="0"/>
           </a:p>
         </p:txBody>
       </p:sp>
@@ -31680,7 +31893,7 @@
         <p:spPr>
           <a:xfrm>
             <a:off x="6583680" y="4206240"/>
-            <a:ext cx="4846320" cy="914400"/>
+            <a:ext cx="4846320" cy="1097280"/>
           </a:xfrm>
           <a:prstGeom prst="rect">
             <a:avLst/>
@@ -31707,7 +31920,7 @@
                 <a:ea typeface="Calibri" pitchFamily="34" charset="-122"/>
                 <a:cs typeface="Calibri" pitchFamily="34" charset="-120"/>
               </a:rPr>
-              <a:t>The compositional logic transfers. The loading case does not.</a:t>
+              <a:t>The compositional logic transfers. The loading case does not, and for an interior surface that is bending.</a:t>
             </a:r>
             <a:endParaRPr lang="en-US" sz="1200" dirty="0"/>
           </a:p>
@@ -32332,7 +32545,7 @@
                 <a:ea typeface="Calibri" pitchFamily="34" charset="-122"/>
                 <a:cs typeface="Calibri" pitchFamily="34" charset="-120"/>
               </a:rPr>
-              <a:t>The contribution is therefore a documented protocol and a single coherent property set, not a novel constituent.</a:t>
+              <a:t>It is not a novel constituent. It is a documented protocol and a single coherent property set.</a:t>
             </a:r>
             <a:endParaRPr lang="en-US" sz="1200" dirty="0"/>
           </a:p>
@@ -32899,7 +33112,49 @@
         </p:nvSpPr>
         <p:spPr>
           <a:xfrm>
-            <a:off x="731520" y="5120640"/>
+            <a:off x="731520" y="4800600"/>
+            <a:ext cx="10241280" cy="457200"/>
+          </a:xfrm>
+          <a:prstGeom prst="rect">
+            <a:avLst/>
+          </a:prstGeom>
+          <a:noFill/>
+          <a:ln/>
+        </p:spPr>
+        <p:txBody>
+          <a:bodyPr wrap="square" lIns="0" tIns="0" rIns="0" bIns="0" rtlCol="0" anchor="t"/>
+          <a:lstStyle/>
+          <a:p>
+            <a:pPr indent="0" marL="0">
+              <a:lnSpc>
+                <a:spcPts val="1800"/>
+              </a:lnSpc>
+              <a:buNone/>
+            </a:pPr>
+            <a:r>
+              <a:rPr lang="en-US" sz="1200" b="1" i="1" dirty="0">
+                <a:solidFill>
+                  <a:srgbClr val="141414"/>
+                </a:solidFill>
+                <a:latin typeface="Calibri" pitchFamily="34" charset="0"/>
+                <a:ea typeface="Calibri" pitchFamily="34" charset="-122"/>
+                <a:cs typeface="Calibri" pitchFamily="34" charset="-120"/>
+              </a:rPr>
+              <a:t>The fourth — deriving an evaluation criterion for this material class — is where I will spend most time.</a:t>
+            </a:r>
+            <a:endParaRPr lang="en-US" sz="1200" dirty="0"/>
+          </a:p>
+        </p:txBody>
+      </p:sp>
+      <p:sp>
+        <p:nvSpPr>
+          <p:cNvPr id="16" name="Text 14"/>
+          <p:cNvSpPr txBox="1"/>
+          <p:nvPr/>
+        </p:nvSpPr>
+        <p:spPr>
+          <a:xfrm>
+            <a:off x="731520" y="5486400"/>
             <a:ext cx="10241280" cy="457200"/>
           </a:xfrm>
           <a:prstGeom prst="rect">
@@ -32935,7 +33190,7 @@
       </p:sp>
       <p:sp>
         <p:nvSpPr>
-          <p:cNvPr id="17" name="Text 0"/>
+          <p:cNvPr id="18" name="Text 0"/>
           <p:cNvSpPr/>
           <p:nvPr>
             <p:ph idx="100" hasCustomPrompt="1"/>
@@ -34848,7 +35103,7 @@
         <p:spPr>
           <a:xfrm>
             <a:off x="731520" y="6263640"/>
-            <a:ext cx="10241280" cy="457200"/>
+            <a:ext cx="10241280" cy="365760"/>
           </a:xfrm>
           <a:prstGeom prst="rect">
             <a:avLst/>
@@ -34862,22 +35117,22 @@
           <a:p>
             <a:pPr indent="0" marL="0">
               <a:lnSpc>
-                <a:spcPts val="1250"/>
+                <a:spcPts val="1800"/>
               </a:lnSpc>
               <a:buNone/>
             </a:pPr>
             <a:r>
-              <a:rPr lang="en-US" sz="900" dirty="0">
+              <a:rPr lang="en-US" sz="1200" b="1" dirty="0">
                 <a:solidFill>
-                  <a:srgbClr val="BDBDBD"/>
+                  <a:srgbClr val="141414"/>
                 </a:solidFill>
                 <a:latin typeface="Calibri" pitchFamily="34" charset="0"/>
                 <a:ea typeface="Calibri" pitchFamily="34" charset="-122"/>
                 <a:cs typeface="Calibri" pitchFamily="34" charset="-120"/>
               </a:rPr>
-              <a:t>Filled: determined in this study. Outlined: not determined, and therefore outside every claim made in this presentation.</a:t>
-            </a:r>
-            <a:endParaRPr lang="en-US" sz="900" dirty="0"/>
+              <a:t>The filled boxes are what was determined. The outlined boxes are what was not.</a:t>
+            </a:r>
+            <a:endParaRPr lang="en-US" sz="1200" dirty="0"/>
           </a:p>
         </p:txBody>
       </p:sp>
@@ -35738,7 +35993,7 @@
                 <a:ea typeface="Calibri" pitchFamily="34" charset="-122"/>
                 <a:cs typeface="Calibri" pitchFamily="34" charset="-120"/>
               </a:rPr>
-              <a:t>Properties first, application envelope second — not the reverse.</a:t>
+              <a:t>Properties first, application envelope second.</a:t>
             </a:r>
             <a:endParaRPr lang="en-US" sz="1200" dirty="0"/>
           </a:p>
@@ -36644,7 +36899,49 @@
       </p:sp>
       <p:sp>
         <p:nvSpPr>
-          <p:cNvPr id="25" name="Text 0"/>
+          <p:cNvPr id="24" name="Text 22"/>
+          <p:cNvSpPr txBox="1"/>
+          <p:nvPr/>
+        </p:nvSpPr>
+        <p:spPr>
+          <a:xfrm>
+            <a:off x="731520" y="6126480"/>
+            <a:ext cx="10241280" cy="365760"/>
+          </a:xfrm>
+          <a:prstGeom prst="rect">
+            <a:avLst/>
+          </a:prstGeom>
+          <a:noFill/>
+          <a:ln/>
+        </p:spPr>
+        <p:txBody>
+          <a:bodyPr wrap="square" lIns="0" tIns="0" rIns="0" bIns="0" rtlCol="0" anchor="t"/>
+          <a:lstStyle/>
+          <a:p>
+            <a:pPr indent="0" marL="0">
+              <a:lnSpc>
+                <a:spcPts val="1800"/>
+              </a:lnSpc>
+              <a:buNone/>
+            </a:pPr>
+            <a:r>
+              <a:rPr lang="en-US" sz="1200" b="1" i="1" dirty="0">
+                <a:solidFill>
+                  <a:srgbClr val="141414"/>
+                </a:solidFill>
+                <a:latin typeface="Calibri" pitchFamily="34" charset="0"/>
+                <a:ea typeface="Calibri" pitchFamily="34" charset="-122"/>
+                <a:cs typeface="Calibri" pitchFamily="34" charset="-120"/>
+              </a:rPr>
+              <a:t>One to four are answered by measurement. Five is answered by argument.</a:t>
+            </a:r>
+            <a:endParaRPr lang="en-US" sz="1200" dirty="0"/>
+          </a:p>
+        </p:txBody>
+      </p:sp>
+      <p:sp>
+        <p:nvSpPr>
+          <p:cNvPr id="26" name="Text 0"/>
           <p:cNvSpPr/>
           <p:nvPr>
             <p:ph idx="100" hasCustomPrompt="1"/>

</xml_diff>